<commit_message>
docs: maj pptx slides 8 et 16 avec headers HTTP et audit OWASP Pentest Toolkit
</commit_message>
<xml_diff>
--- a/meeting/The Library Projet Web Bibliothèque.pptx
+++ b/meeting/The Library Projet Web Bibliothèque.pptx
@@ -14612,7 +14612,7 @@
                 <a:latin typeface="Montserrat Light"/>
                 <a:ea typeface="Montserrat Light"/>
               </a:rPr>
-              <a:t>Conclusion : notre code respecte les bonnes pratiques de sécurité Python. Aucune vulnérabilité connue détectée par l'outil de référence OWASP. Intégration possible dans pipeline CI/CD.</a:t>
+              <a:t>Audit dynamique OWASP Pentest Toolkit : headers HTTP absents des pages HTML. Risques détectés : clickjacking (X-Frame-Options), MIME sniffing (X-Content-Type-Options), XSS élargi (CSP). Correctif appliqué : after_request global dans app.py — headers couvrent toutes les routes HTML et API.</a:t>
             </a:r>
             <a:endParaRPr lang="en-GB" sz="1600" b="0" u="none" strike="noStrike">
               <a:solidFill>
@@ -29164,7 +29164,7 @@
                 <a:latin typeface="Montserrat"/>
                 <a:ea typeface="Montserrat"/>
               </a:rPr>
-              <a:t>• Isolation des données</a:t>
+              <a:t>• Headers HTTP globaux</a:t>
             </a:r>
             <a:endParaRPr lang="en-GB" sz="1600" b="0" u="none" strike="noStrike">
               <a:solidFill>

</xml_diff>